<commit_message>
changed 0 lead time with r
</commit_message>
<xml_diff>
--- a/chapter_05/figures/rainfall_based_ff_verif_overall_scores.pptx
+++ b/chapter_05/figures/rainfall_based_ff_verif_overall_scores.pptx
@@ -115,7 +115,7 @@
 <file path=ppt/revisionInfo.xml><?xml version="1.0" encoding="utf-8"?>
 <p1510:revInfo xmlns:a="http://schemas.openxmlformats.org/drawingml/2006/main" xmlns:r="http://schemas.openxmlformats.org/officeDocument/2006/relationships" xmlns:p1510="http://schemas.microsoft.com/office/powerpoint/2015/10/main">
   <p1510:revLst>
-    <p1510:client id="{9D3BEDD0-040A-4BF7-ABF9-D0FF9D49D355}" v="4" dt="2026-01-26T21:39:49.021"/>
+    <p1510:client id="{9D3BEDD0-040A-4BF7-ABF9-D0FF9D49D355}" v="7" dt="2026-01-26T21:49:16.567"/>
   </p1510:revLst>
 </p1510:revInfo>
 </file>
@@ -125,12 +125,12 @@
   <pc:docChgLst>
     <pc:chgData name="Fatima Pillosu" userId="a6295d4dc9e22643" providerId="LiveId" clId="{87453732-75AC-4426-B5D3-B7C69C2D4F54}"/>
     <pc:docChg chg="custSel modSld">
-      <pc:chgData name="Fatima Pillosu" userId="a6295d4dc9e22643" providerId="LiveId" clId="{87453732-75AC-4426-B5D3-B7C69C2D4F54}" dt="2026-01-26T21:42:02.411" v="302" actId="166"/>
+      <pc:chgData name="Fatima Pillosu" userId="a6295d4dc9e22643" providerId="LiveId" clId="{87453732-75AC-4426-B5D3-B7C69C2D4F54}" dt="2026-01-26T21:49:45.276" v="331" actId="255"/>
       <pc:docMkLst>
         <pc:docMk/>
       </pc:docMkLst>
       <pc:sldChg chg="addSp delSp modSp mod">
-        <pc:chgData name="Fatima Pillosu" userId="a6295d4dc9e22643" providerId="LiveId" clId="{87453732-75AC-4426-B5D3-B7C69C2D4F54}" dt="2026-01-26T21:42:02.411" v="302" actId="166"/>
+        <pc:chgData name="Fatima Pillosu" userId="a6295d4dc9e22643" providerId="LiveId" clId="{87453732-75AC-4426-B5D3-B7C69C2D4F54}" dt="2026-01-26T21:49:45.276" v="331" actId="255"/>
         <pc:sldMkLst>
           <pc:docMk/>
           <pc:sldMk cId="4122425894" sldId="256"/>
@@ -263,6 +263,22 @@
             <ac:spMk id="21" creationId="{FDE335CC-8232-5A7B-BA6B-67F73B52FE52}"/>
           </ac:spMkLst>
         </pc:spChg>
+        <pc:spChg chg="add mod ord">
+          <ac:chgData name="Fatima Pillosu" userId="a6295d4dc9e22643" providerId="LiveId" clId="{87453732-75AC-4426-B5D3-B7C69C2D4F54}" dt="2026-01-26T21:49:45.276" v="331" actId="255"/>
+          <ac:spMkLst>
+            <pc:docMk/>
+            <pc:sldMk cId="4122425894" sldId="256"/>
+            <ac:spMk id="23" creationId="{A0861819-C13A-4211-B3E9-87674CC9E37D}"/>
+          </ac:spMkLst>
+        </pc:spChg>
+        <pc:spChg chg="add mod">
+          <ac:chgData name="Fatima Pillosu" userId="a6295d4dc9e22643" providerId="LiveId" clId="{87453732-75AC-4426-B5D3-B7C69C2D4F54}" dt="2026-01-26T21:48:49.456" v="320" actId="14100"/>
+          <ac:spMkLst>
+            <pc:docMk/>
+            <pc:sldMk cId="4122425894" sldId="256"/>
+            <ac:spMk id="24" creationId="{1F88BE76-F612-4EDE-475B-2CDCA7A4AC03}"/>
+          </ac:spMkLst>
+        </pc:spChg>
         <pc:spChg chg="add del mod">
           <ac:chgData name="Fatima Pillosu" userId="a6295d4dc9e22643" providerId="LiveId" clId="{87453732-75AC-4426-B5D3-B7C69C2D4F54}" dt="2026-01-26T21:37:55.954" v="188" actId="478"/>
           <ac:spMkLst>
@@ -277,6 +293,22 @@
             <pc:docMk/>
             <pc:sldMk cId="4122425894" sldId="256"/>
             <ac:spMk id="25" creationId="{7382BBAC-0F4E-A979-DC59-08506F4D434A}"/>
+          </ac:spMkLst>
+        </pc:spChg>
+        <pc:spChg chg="add mod">
+          <ac:chgData name="Fatima Pillosu" userId="a6295d4dc9e22643" providerId="LiveId" clId="{87453732-75AC-4426-B5D3-B7C69C2D4F54}" dt="2026-01-26T21:49:24.415" v="326" actId="1076"/>
+          <ac:spMkLst>
+            <pc:docMk/>
+            <pc:sldMk cId="4122425894" sldId="256"/>
+            <ac:spMk id="26" creationId="{879D0017-9156-BDB4-636F-ED86CE8CE57C}"/>
+          </ac:spMkLst>
+        </pc:spChg>
+        <pc:spChg chg="add mod">
+          <ac:chgData name="Fatima Pillosu" userId="a6295d4dc9e22643" providerId="LiveId" clId="{87453732-75AC-4426-B5D3-B7C69C2D4F54}" dt="2026-01-26T21:49:36.508" v="329" actId="255"/>
+          <ac:spMkLst>
+            <pc:docMk/>
+            <pc:sldMk cId="4122425894" sldId="256"/>
+            <ac:spMk id="27" creationId="{E88E6EB5-936B-D36B-D075-177C9C23B59D}"/>
           </ac:spMkLst>
         </pc:spChg>
         <pc:spChg chg="mod">
@@ -5407,6 +5439,168 @@
           </p:txBody>
         </p:sp>
       </p:grpSp>
+      <p:sp>
+        <p:nvSpPr>
+          <p:cNvPr id="24" name="TextBox 23">
+            <a:extLst>
+              <a:ext uri="{FF2B5EF4-FFF2-40B4-BE49-F238E27FC236}">
+                <a16:creationId xmlns:a16="http://schemas.microsoft.com/office/drawing/2014/main" id="{1F88BE76-F612-4EDE-475B-2CDCA7A4AC03}"/>
+              </a:ext>
+            </a:extLst>
+          </p:cNvPr>
+          <p:cNvSpPr txBox="1"/>
+          <p:nvPr/>
+        </p:nvSpPr>
+        <p:spPr>
+          <a:xfrm>
+            <a:off x="284056" y="2714875"/>
+            <a:ext cx="134317" cy="153003"/>
+          </a:xfrm>
+          <a:prstGeom prst="rect">
+            <a:avLst/>
+          </a:prstGeom>
+          <a:solidFill>
+            <a:schemeClr val="bg1"/>
+          </a:solidFill>
+        </p:spPr>
+        <p:txBody>
+          <a:bodyPr wrap="square" rtlCol="0">
+            <a:spAutoFit/>
+          </a:bodyPr>
+          <a:lstStyle/>
+          <a:p>
+            <a:endParaRPr lang="en-US" sz="600" dirty="0">
+              <a:solidFill>
+                <a:srgbClr val="333333"/>
+              </a:solidFill>
+              <a:latin typeface="Calibri Light" panose="020F0302020204030204" pitchFamily="34" charset="0"/>
+              <a:cs typeface="Calibri Light" panose="020F0302020204030204" pitchFamily="34" charset="0"/>
+            </a:endParaRPr>
+          </a:p>
+        </p:txBody>
+      </p:sp>
+      <p:sp>
+        <p:nvSpPr>
+          <p:cNvPr id="23" name="TextBox 22">
+            <a:extLst>
+              <a:ext uri="{FF2B5EF4-FFF2-40B4-BE49-F238E27FC236}">
+                <a16:creationId xmlns:a16="http://schemas.microsoft.com/office/drawing/2014/main" id="{A0861819-C13A-4211-B3E9-87674CC9E37D}"/>
+              </a:ext>
+            </a:extLst>
+          </p:cNvPr>
+          <p:cNvSpPr txBox="1"/>
+          <p:nvPr/>
+        </p:nvSpPr>
+        <p:spPr>
+          <a:xfrm>
+            <a:off x="237763" y="2650968"/>
+            <a:ext cx="194577" cy="200055"/>
+          </a:xfrm>
+          <a:prstGeom prst="rect">
+            <a:avLst/>
+          </a:prstGeom>
+          <a:noFill/>
+        </p:spPr>
+        <p:txBody>
+          <a:bodyPr wrap="square" rtlCol="0">
+            <a:spAutoFit/>
+          </a:bodyPr>
+          <a:lstStyle/>
+          <a:p>
+            <a:r>
+              <a:rPr lang="en-US" sz="700" dirty="0">
+                <a:solidFill>
+                  <a:srgbClr val="333333"/>
+                </a:solidFill>
+                <a:latin typeface="Calibri Light" panose="020F0302020204030204" pitchFamily="34" charset="0"/>
+                <a:cs typeface="Calibri Light" panose="020F0302020204030204" pitchFamily="34" charset="0"/>
+              </a:rPr>
+              <a:t>r</a:t>
+            </a:r>
+          </a:p>
+        </p:txBody>
+      </p:sp>
+      <p:sp>
+        <p:nvSpPr>
+          <p:cNvPr id="26" name="TextBox 25">
+            <a:extLst>
+              <a:ext uri="{FF2B5EF4-FFF2-40B4-BE49-F238E27FC236}">
+                <a16:creationId xmlns:a16="http://schemas.microsoft.com/office/drawing/2014/main" id="{879D0017-9156-BDB4-636F-ED86CE8CE57C}"/>
+              </a:ext>
+            </a:extLst>
+          </p:cNvPr>
+          <p:cNvSpPr txBox="1"/>
+          <p:nvPr/>
+        </p:nvSpPr>
+        <p:spPr>
+          <a:xfrm>
+            <a:off x="2418173" y="2708235"/>
+            <a:ext cx="134317" cy="153003"/>
+          </a:xfrm>
+          <a:prstGeom prst="rect">
+            <a:avLst/>
+          </a:prstGeom>
+          <a:solidFill>
+            <a:schemeClr val="bg1"/>
+          </a:solidFill>
+        </p:spPr>
+        <p:txBody>
+          <a:bodyPr wrap="square" rtlCol="0">
+            <a:spAutoFit/>
+          </a:bodyPr>
+          <a:lstStyle/>
+          <a:p>
+            <a:endParaRPr lang="en-US" sz="600" dirty="0">
+              <a:solidFill>
+                <a:srgbClr val="333333"/>
+              </a:solidFill>
+              <a:latin typeface="Calibri Light" panose="020F0302020204030204" pitchFamily="34" charset="0"/>
+              <a:cs typeface="Calibri Light" panose="020F0302020204030204" pitchFamily="34" charset="0"/>
+            </a:endParaRPr>
+          </a:p>
+        </p:txBody>
+      </p:sp>
+      <p:sp>
+        <p:nvSpPr>
+          <p:cNvPr id="27" name="TextBox 26">
+            <a:extLst>
+              <a:ext uri="{FF2B5EF4-FFF2-40B4-BE49-F238E27FC236}">
+                <a16:creationId xmlns:a16="http://schemas.microsoft.com/office/drawing/2014/main" id="{E88E6EB5-936B-D36B-D075-177C9C23B59D}"/>
+              </a:ext>
+            </a:extLst>
+          </p:cNvPr>
+          <p:cNvSpPr txBox="1"/>
+          <p:nvPr/>
+        </p:nvSpPr>
+        <p:spPr>
+          <a:xfrm>
+            <a:off x="2371880" y="2644328"/>
+            <a:ext cx="194577" cy="200055"/>
+          </a:xfrm>
+          <a:prstGeom prst="rect">
+            <a:avLst/>
+          </a:prstGeom>
+          <a:noFill/>
+        </p:spPr>
+        <p:txBody>
+          <a:bodyPr wrap="square" rtlCol="0">
+            <a:spAutoFit/>
+          </a:bodyPr>
+          <a:lstStyle/>
+          <a:p>
+            <a:r>
+              <a:rPr lang="en-US" sz="700" dirty="0">
+                <a:solidFill>
+                  <a:srgbClr val="333333"/>
+                </a:solidFill>
+                <a:latin typeface="Calibri Light" panose="020F0302020204030204" pitchFamily="34" charset="0"/>
+                <a:cs typeface="Calibri Light" panose="020F0302020204030204" pitchFamily="34" charset="0"/>
+              </a:rPr>
+              <a:t>r</a:t>
+            </a:r>
+          </a:p>
+        </p:txBody>
+      </p:sp>
     </p:spTree>
     <p:extLst>
       <p:ext uri="{BB962C8B-B14F-4D97-AF65-F5344CB8AC3E}">

</xml_diff>